<commit_message>
Match linking-words exercise to reference template
</commit_message>
<xml_diff>
--- a/deliverables/PET_Free_Time_Activities.pptx
+++ b/deliverables/PET_Free_Time_Activities.pptx
@@ -661,7 +661,32 @@
           <a:lstStyle/>
           <a:p>
             <a:r>
-              <a:t>先给学生思考时间，再逐题单击。单击1：because；单击2：For example / For instance，二者都接受；单击3：also。也可接受其他符合语义与句法的表达，例如第1题 since；应解释为什么成立。不要要求每个词只能用一次。</a:t>
+              <a:t>完整短文填空，参照 Wild Animals 模板：词库在上，连续短文在下，答案在空格原位出现。</a:t>
+            </a:r>
+          </a:p>
+          <a:p>
+            <a:r>
+              <a:t>初始只显示词库、短文与空格。每次鼠标单击出现一个绿色底、黄色字的答案框；无自动播放。</a:t>
+            </a:r>
+          </a:p>
+          <a:p>
+            <a:r>
+              <a:t>单击顺序：1 Firstly；2 For example；3 because；4 also；5 For instance；6 so；7 Finally。</a:t>
+            </a:r>
+          </a:p>
+          <a:p>
+            <a:r>
+              <a:t>第2、5空均接受 For example 或 For instance；不因互换而判错，也不强制每个表达只用一次。</a:t>
+            </a:r>
+          </a:p>
+          <a:p>
+            <a:r>
+              <a:t>先请学生解释原因、举例、补充和结果的关系，再逐空核对。Firstly/Finally 组织观点顺序。</a:t>
+            </a:r>
+          </a:p>
+          <a:p>
+            <a:r>
+              <a:t>班级、场地和周末活动为示例情境，学生可使用自己的真实细节。</a:t>
             </a:r>
           </a:p>
         </p:txBody>
@@ -6263,8 +6288,8 @@
         </p:nvSpPr>
         <p:spPr>
           <a:xfrm>
-            <a:off x="822960" y="5989320"/>
-            <a:ext cx="10607040" cy="320040"/>
+            <a:off x="822960" y="5925312"/>
+            <a:ext cx="10607040" cy="393192"/>
           </a:xfrm>
           <a:prstGeom prst="rect">
             <a:avLst/>
@@ -6297,7 +6322,7 @@
                 <a:ea typeface="Microsoft YaHei"/>
                 <a:cs typeface="Microsoft YaHei"/>
               </a:rPr>
-              <a:t>for example / for instance 通常可互换；连接词不必全部使用。</a:t>
+              <a:t>firstly / finally：安排顺序；for example / for instance：通常可互换。</a:t>
             </a:r>
           </a:p>
         </p:txBody>
@@ -6595,8 +6620,8 @@
         </p:nvSpPr>
         <p:spPr>
           <a:xfrm>
-            <a:off x="502920" y="256032"/>
-            <a:ext cx="11109960" cy="640080"/>
+            <a:off x="502920" y="201168"/>
+            <a:ext cx="11155680" cy="658368"/>
           </a:xfrm>
           <a:prstGeom prst="rect">
             <a:avLst/>
@@ -6623,13 +6648,13 @@
             <a:r>
               <a:rPr sz="3200" b="1">
                 <a:solidFill>
-                  <a:srgbClr val="367DB1"/>
+                  <a:srgbClr val="17365D"/>
                 </a:solidFill>
                 <a:latin typeface="Microsoft YaHei"/>
                 <a:ea typeface="Microsoft YaHei"/>
                 <a:cs typeface="Microsoft YaHei"/>
               </a:rPr>
-              <a:t>10. Linking words: your turn</a:t>
+              <a:t>10. Linking words: fill in the blanks</a:t>
             </a:r>
           </a:p>
         </p:txBody>
@@ -6642,8 +6667,8 @@
         </p:nvSpPr>
         <p:spPr>
           <a:xfrm>
-            <a:off x="530352" y="941832"/>
-            <a:ext cx="11064240" cy="429768"/>
+            <a:off x="548640" y="896112"/>
+            <a:ext cx="11064240" cy="420624"/>
           </a:xfrm>
           <a:prstGeom prst="rect">
             <a:avLst/>
@@ -6668,7 +6693,7 @@
               </a:spcAft>
             </a:pPr>
             <a:r>
-              <a:rPr sz="1900" b="0">
+              <a:rPr sz="1800" b="0">
                 <a:solidFill>
                   <a:srgbClr val="5A6978"/>
                 </a:solidFill>
@@ -6676,30 +6701,34 @@
                 <a:ea typeface="Microsoft YaHei"/>
                 <a:cs typeface="Microsoft YaHei"/>
               </a:rPr>
-              <a:t>连接词练习｜先口头补全句子；举例处接受两种合理表达。</a:t>
-            </a:r>
-          </a:p>
-        </p:txBody>
-      </p:sp>
-      <p:sp>
-        <p:nvSpPr>
-          <p:cNvPr id="5" name="Rectangle 4"/>
+              <a:t>连接词练习｜从词库选词补全短文；单击逐空揭晓。举例表达可互换。</a:t>
+            </a:r>
+          </a:p>
+        </p:txBody>
+      </p:sp>
+      <p:sp>
+        <p:nvSpPr>
+          <p:cNvPr id="5" name="Rounded Rectangle 4"/>
           <p:cNvSpPr/>
           <p:nvPr/>
         </p:nvSpPr>
         <p:spPr>
           <a:xfrm>
-            <a:off x="621792" y="6419088"/>
-            <a:ext cx="10945368" cy="10972"/>
-          </a:xfrm>
-          <a:prstGeom prst="rect">
-            <a:avLst/>
+            <a:off x="713232" y="1344168"/>
+            <a:ext cx="10835640" cy="932688"/>
+          </a:xfrm>
+          <a:prstGeom prst="roundRect">
+            <a:avLst>
+              <a:gd name="adj" fmla="val 8000"/>
+            </a:avLst>
           </a:prstGeom>
           <a:solidFill>
-            <a:srgbClr val="CBDCE9"/>
+            <a:srgbClr val="EEF5FB"/>
           </a:solidFill>
-          <a:ln>
-            <a:noFill/>
+          <a:ln w="10160">
+            <a:solidFill>
+              <a:srgbClr val="367DB1"/>
+            </a:solidFill>
           </a:ln>
         </p:spPr>
         <p:style>
@@ -6732,7 +6761,1789 @@
         </p:nvSpPr>
         <p:spPr>
           <a:xfrm>
-            <a:off x="594360" y="6510528"/>
+            <a:off x="804672" y="1362456"/>
+            <a:ext cx="10652760" cy="896112"/>
+          </a:xfrm>
+          <a:prstGeom prst="rect">
+            <a:avLst/>
+          </a:prstGeom>
+          <a:noFill/>
+        </p:spPr>
+        <p:txBody>
+          <a:bodyPr wrap="square" lIns="109728" rIns="109728" anchor="ctr">
+            <a:spAutoFit/>
+          </a:bodyPr>
+          <a:lstStyle/>
+          <a:p>
+            <a:pPr algn="ctr">
+              <a:lnSpc>
+                <a:spcPts val="2800"/>
+              </a:lnSpc>
+              <a:spcBef>
+                <a:spcPts val="0"/>
+              </a:spcBef>
+              <a:spcAft>
+                <a:spcPts val="0"/>
+              </a:spcAft>
+            </a:pPr>
+            <a:r>
+              <a:rPr sz="2400" b="1">
+                <a:solidFill>
+                  <a:srgbClr val="17365D"/>
+                </a:solidFill>
+                <a:latin typeface="Microsoft YaHei"/>
+                <a:ea typeface="Microsoft YaHei"/>
+                <a:cs typeface="Microsoft YaHei"/>
+              </a:rPr>
+              <a:t>also  ·  because  ·  finally  ·  firstly</a:t>
+            </a:r>
+          </a:p>
+          <a:p>
+            <a:pPr algn="ctr">
+              <a:lnSpc>
+                <a:spcPts val="2800"/>
+              </a:lnSpc>
+              <a:spcBef>
+                <a:spcPts val="0"/>
+              </a:spcBef>
+              <a:spcAft>
+                <a:spcPts val="0"/>
+              </a:spcAft>
+            </a:pPr>
+            <a:r>
+              <a:rPr sz="2400" b="1">
+                <a:solidFill>
+                  <a:srgbClr val="17365D"/>
+                </a:solidFill>
+                <a:latin typeface="Microsoft YaHei"/>
+                <a:ea typeface="Microsoft YaHei"/>
+                <a:cs typeface="Microsoft YaHei"/>
+              </a:rPr>
+              <a:t>for example  ·  for instance  ·  so</a:t>
+            </a:r>
+          </a:p>
+        </p:txBody>
+      </p:sp>
+      <p:sp>
+        <p:nvSpPr>
+          <p:cNvPr id="7" name="TextBox 6"/>
+          <p:cNvSpPr txBox="1"/>
+          <p:nvPr/>
+        </p:nvSpPr>
+        <p:spPr>
+          <a:xfrm>
+            <a:off x="731520" y="2441448"/>
+            <a:ext cx="8696881" cy="438912"/>
+          </a:xfrm>
+          <a:prstGeom prst="rect">
+            <a:avLst/>
+          </a:prstGeom>
+          <a:noFill/>
+        </p:spPr>
+        <p:txBody>
+          <a:bodyPr wrap="none" lIns="0" rIns="0" anchor="ctr" tIns="0" bIns="0">
+            <a:noAutofit/>
+          </a:bodyPr>
+          <a:lstStyle/>
+          <a:p>
+            <a:pPr>
+              <a:lnSpc>
+                <a:spcPts val="2850"/>
+              </a:lnSpc>
+              <a:spcBef>
+                <a:spcPts val="0"/>
+              </a:spcBef>
+              <a:spcAft>
+                <a:spcPts val="0"/>
+              </a:spcAft>
+            </a:pPr>
+            <a:r>
+              <a:rPr sz="2400" b="0">
+                <a:solidFill>
+                  <a:srgbClr val="101010"/>
+                </a:solidFill>
+                <a:latin typeface="Microsoft YaHei"/>
+                <a:ea typeface="Microsoft YaHei"/>
+                <a:cs typeface="Microsoft YaHei"/>
+              </a:rPr>
+              <a:t>Have you ever played basketball with your friends? In China,</a:t>
+            </a:r>
+          </a:p>
+        </p:txBody>
+      </p:sp>
+      <p:sp>
+        <p:nvSpPr>
+          <p:cNvPr id="8" name="TextBox 7"/>
+          <p:cNvSpPr txBox="1"/>
+          <p:nvPr/>
+        </p:nvSpPr>
+        <p:spPr>
+          <a:xfrm>
+            <a:off x="731520" y="2871215"/>
+            <a:ext cx="4601545" cy="438912"/>
+          </a:xfrm>
+          <a:prstGeom prst="rect">
+            <a:avLst/>
+          </a:prstGeom>
+          <a:noFill/>
+        </p:spPr>
+        <p:txBody>
+          <a:bodyPr wrap="none" lIns="0" rIns="0" anchor="ctr" tIns="0" bIns="0">
+            <a:noAutofit/>
+          </a:bodyPr>
+          <a:lstStyle/>
+          <a:p>
+            <a:pPr>
+              <a:lnSpc>
+                <a:spcPts val="2850"/>
+              </a:lnSpc>
+              <a:spcBef>
+                <a:spcPts val="0"/>
+              </a:spcBef>
+              <a:spcAft>
+                <a:spcPts val="0"/>
+              </a:spcAft>
+            </a:pPr>
+            <a:r>
+              <a:rPr sz="2400" b="0">
+                <a:solidFill>
+                  <a:srgbClr val="101010"/>
+                </a:solidFill>
+                <a:latin typeface="Microsoft YaHei"/>
+                <a:ea typeface="Microsoft YaHei"/>
+                <a:cs typeface="Microsoft YaHei"/>
+              </a:rPr>
+              <a:t>it is popular with young people.</a:t>
+            </a:r>
+          </a:p>
+        </p:txBody>
+      </p:sp>
+      <p:cxnSp>
+        <p:nvCxnSpPr>
+          <p:cNvPr id="9" name="Connector 8"/>
+          <p:cNvCxnSpPr/>
+          <p:nvPr/>
+        </p:nvCxnSpPr>
+        <p:spPr>
+          <a:xfrm>
+            <a:off x="754380" y="3671315"/>
+            <a:ext cx="1188720" cy="0"/>
+          </a:xfrm>
+          <a:prstGeom prst="line">
+            <a:avLst/>
+          </a:prstGeom>
+          <a:ln w="10795">
+            <a:solidFill>
+              <a:srgbClr val="17365D"/>
+            </a:solidFill>
+          </a:ln>
+        </p:spPr>
+        <p:style>
+          <a:lnRef idx="2">
+            <a:schemeClr val="accent1"/>
+          </a:lnRef>
+          <a:fillRef idx="0">
+            <a:schemeClr val="accent1"/>
+          </a:fillRef>
+          <a:effectRef idx="1">
+            <a:schemeClr val="accent1"/>
+          </a:effectRef>
+          <a:fontRef idx="minor">
+            <a:schemeClr val="tx1"/>
+          </a:fontRef>
+        </p:style>
+      </p:cxnSp>
+      <p:grpSp>
+        <p:nvGrpSpPr>
+          <p:cNvPr id="10" name="Group 9"/>
+          <p:cNvGrpSpPr/>
+          <p:nvPr/>
+        </p:nvGrpSpPr>
+        <p:grpSpPr>
+          <a:xfrm>
+            <a:off x="731520" y="3317443"/>
+            <a:ext cx="1234440" cy="411480"/>
+            <a:chOff x="731520" y="3317443"/>
+            <a:chExt cx="1234440" cy="411480"/>
+          </a:xfrm>
+        </p:grpSpPr>
+        <p:sp>
+          <p:nvSpPr>
+            <p:cNvPr id="11" name="Rounded Rectangle 10"/>
+            <p:cNvSpPr/>
+            <p:nvPr/>
+          </p:nvSpPr>
+          <p:spPr>
+            <a:xfrm>
+              <a:off x="731520" y="3323844"/>
+              <a:ext cx="1234440" cy="393192"/>
+            </a:xfrm>
+            <a:prstGeom prst="roundRect">
+              <a:avLst>
+                <a:gd name="adj" fmla="val 8000"/>
+              </a:avLst>
+            </a:prstGeom>
+            <a:solidFill>
+              <a:srgbClr val="718B2E"/>
+            </a:solidFill>
+            <a:ln w="10160">
+              <a:solidFill>
+                <a:srgbClr val="6B95B6"/>
+              </a:solidFill>
+            </a:ln>
+            <a:effectLst>
+              <a:outerShdw blurRad="25400" dist="19050" dir="5400000" algn="ctr" rotWithShape="0">
+                <a:srgbClr val="000000">
+                  <a:alpha val="22000"/>
+                </a:srgbClr>
+              </a:outerShdw>
+            </a:effectLst>
+          </p:spPr>
+          <p:style>
+            <a:lnRef idx="1">
+              <a:schemeClr val="accent1"/>
+            </a:lnRef>
+            <a:fillRef idx="3">
+              <a:schemeClr val="accent1"/>
+            </a:fillRef>
+            <a:effectRef idx="2">
+              <a:schemeClr val="accent1"/>
+            </a:effectRef>
+            <a:fontRef idx="minor">
+              <a:schemeClr val="lt1"/>
+            </a:fontRef>
+          </p:style>
+          <p:txBody>
+            <a:bodyPr rtlCol="0" anchor="ctr"/>
+            <a:lstStyle/>
+            <a:p>
+              <a:pPr algn="ctr"/>
+            </a:p>
+          </p:txBody>
+        </p:sp>
+        <p:sp>
+          <p:nvSpPr>
+            <p:cNvPr id="12" name="TextBox 11"/>
+            <p:cNvSpPr txBox="1"/>
+            <p:nvPr/>
+          </p:nvSpPr>
+          <p:spPr>
+            <a:xfrm>
+              <a:off x="745236" y="3317443"/>
+              <a:ext cx="1207008" cy="411480"/>
+            </a:xfrm>
+            <a:prstGeom prst="rect">
+              <a:avLst/>
+            </a:prstGeom>
+            <a:noFill/>
+          </p:spPr>
+          <p:txBody>
+            <a:bodyPr wrap="square" lIns="0" rIns="0" anchor="ctr" tIns="0" bIns="0">
+              <a:spAutoFit/>
+            </a:bodyPr>
+            <a:lstStyle/>
+            <a:p>
+              <a:pPr algn="ctr">
+                <a:lnSpc>
+                  <a:spcPts val="2400"/>
+                </a:lnSpc>
+                <a:spcBef>
+                  <a:spcPts val="0"/>
+                </a:spcBef>
+                <a:spcAft>
+                  <a:spcPts val="0"/>
+                </a:spcAft>
+              </a:pPr>
+              <a:r>
+                <a:rPr sz="2000" b="1">
+                  <a:solidFill>
+                    <a:srgbClr val="FFFF00"/>
+                  </a:solidFill>
+                  <a:latin typeface="Microsoft YaHei"/>
+                  <a:ea typeface="Microsoft YaHei"/>
+                  <a:cs typeface="Microsoft YaHei"/>
+                </a:rPr>
+                <a:t>Firstly</a:t>
+              </a:r>
+            </a:p>
+          </p:txBody>
+        </p:sp>
+      </p:grpSp>
+      <p:sp>
+        <p:nvSpPr>
+          <p:cNvPr id="13" name="TextBox 12"/>
+          <p:cNvSpPr txBox="1"/>
+          <p:nvPr/>
+        </p:nvSpPr>
+        <p:spPr>
+          <a:xfrm>
+            <a:off x="1965960" y="3300984"/>
+            <a:ext cx="6349373" cy="438912"/>
+          </a:xfrm>
+          <a:prstGeom prst="rect">
+            <a:avLst/>
+          </a:prstGeom>
+          <a:noFill/>
+        </p:spPr>
+        <p:txBody>
+          <a:bodyPr wrap="none" lIns="0" rIns="0" anchor="ctr" tIns="0" bIns="0">
+            <a:noAutofit/>
+          </a:bodyPr>
+          <a:lstStyle/>
+          <a:p>
+            <a:pPr>
+              <a:lnSpc>
+                <a:spcPts val="2850"/>
+              </a:lnSpc>
+              <a:spcBef>
+                <a:spcPts val="0"/>
+              </a:spcBef>
+              <a:spcAft>
+                <a:spcPts val="0"/>
+              </a:spcAft>
+            </a:pPr>
+            <a:r>
+              <a:rPr sz="2400" b="0">
+                <a:solidFill>
+                  <a:srgbClr val="101010"/>
+                </a:solidFill>
+                <a:latin typeface="Microsoft YaHei"/>
+                <a:ea typeface="Microsoft YaHei"/>
+                <a:cs typeface="Microsoft YaHei"/>
+              </a:rPr>
+              <a:t>, it is a great way to spend time with friends.</a:t>
+            </a:r>
+          </a:p>
+        </p:txBody>
+      </p:sp>
+      <p:cxnSp>
+        <p:nvCxnSpPr>
+          <p:cNvPr id="14" name="Connector 13"/>
+          <p:cNvCxnSpPr/>
+          <p:nvPr/>
+        </p:nvCxnSpPr>
+        <p:spPr>
+          <a:xfrm>
+            <a:off x="754380" y="4101084"/>
+            <a:ext cx="1874520" cy="0"/>
+          </a:xfrm>
+          <a:prstGeom prst="line">
+            <a:avLst/>
+          </a:prstGeom>
+          <a:ln w="10795">
+            <a:solidFill>
+              <a:srgbClr val="17365D"/>
+            </a:solidFill>
+          </a:ln>
+        </p:spPr>
+        <p:style>
+          <a:lnRef idx="2">
+            <a:schemeClr val="accent1"/>
+          </a:lnRef>
+          <a:fillRef idx="0">
+            <a:schemeClr val="accent1"/>
+          </a:fillRef>
+          <a:effectRef idx="1">
+            <a:schemeClr val="accent1"/>
+          </a:effectRef>
+          <a:fontRef idx="minor">
+            <a:schemeClr val="tx1"/>
+          </a:fontRef>
+        </p:style>
+      </p:cxnSp>
+      <p:grpSp>
+        <p:nvGrpSpPr>
+          <p:cNvPr id="15" name="Group 14"/>
+          <p:cNvGrpSpPr/>
+          <p:nvPr/>
+        </p:nvGrpSpPr>
+        <p:grpSpPr>
+          <a:xfrm>
+            <a:off x="731520" y="3747211"/>
+            <a:ext cx="1920240" cy="411480"/>
+            <a:chOff x="731520" y="3747211"/>
+            <a:chExt cx="1920240" cy="411480"/>
+          </a:xfrm>
+        </p:grpSpPr>
+        <p:sp>
+          <p:nvSpPr>
+            <p:cNvPr id="16" name="Rounded Rectangle 15"/>
+            <p:cNvSpPr/>
+            <p:nvPr/>
+          </p:nvSpPr>
+          <p:spPr>
+            <a:xfrm>
+              <a:off x="731520" y="3753612"/>
+              <a:ext cx="1920240" cy="393192"/>
+            </a:xfrm>
+            <a:prstGeom prst="roundRect">
+              <a:avLst>
+                <a:gd name="adj" fmla="val 8000"/>
+              </a:avLst>
+            </a:prstGeom>
+            <a:solidFill>
+              <a:srgbClr val="718B2E"/>
+            </a:solidFill>
+            <a:ln w="10160">
+              <a:solidFill>
+                <a:srgbClr val="6B95B6"/>
+              </a:solidFill>
+            </a:ln>
+            <a:effectLst>
+              <a:outerShdw blurRad="25400" dist="19050" dir="5400000" algn="ctr" rotWithShape="0">
+                <a:srgbClr val="000000">
+                  <a:alpha val="22000"/>
+                </a:srgbClr>
+              </a:outerShdw>
+            </a:effectLst>
+          </p:spPr>
+          <p:style>
+            <a:lnRef idx="1">
+              <a:schemeClr val="accent1"/>
+            </a:lnRef>
+            <a:fillRef idx="3">
+              <a:schemeClr val="accent1"/>
+            </a:fillRef>
+            <a:effectRef idx="2">
+              <a:schemeClr val="accent1"/>
+            </a:effectRef>
+            <a:fontRef idx="minor">
+              <a:schemeClr val="lt1"/>
+            </a:fontRef>
+          </p:style>
+          <p:txBody>
+            <a:bodyPr rtlCol="0" anchor="ctr"/>
+            <a:lstStyle/>
+            <a:p>
+              <a:pPr algn="ctr"/>
+            </a:p>
+          </p:txBody>
+        </p:sp>
+        <p:sp>
+          <p:nvSpPr>
+            <p:cNvPr id="17" name="TextBox 16"/>
+            <p:cNvSpPr txBox="1"/>
+            <p:nvPr/>
+          </p:nvSpPr>
+          <p:spPr>
+            <a:xfrm>
+              <a:off x="745236" y="3747211"/>
+              <a:ext cx="1892808" cy="411480"/>
+            </a:xfrm>
+            <a:prstGeom prst="rect">
+              <a:avLst/>
+            </a:prstGeom>
+            <a:noFill/>
+          </p:spPr>
+          <p:txBody>
+            <a:bodyPr wrap="square" lIns="0" rIns="0" anchor="ctr" tIns="0" bIns="0">
+              <a:spAutoFit/>
+            </a:bodyPr>
+            <a:lstStyle/>
+            <a:p>
+              <a:pPr algn="ctr">
+                <a:lnSpc>
+                  <a:spcPts val="2400"/>
+                </a:lnSpc>
+                <a:spcBef>
+                  <a:spcPts val="0"/>
+                </a:spcBef>
+                <a:spcAft>
+                  <a:spcPts val="0"/>
+                </a:spcAft>
+              </a:pPr>
+              <a:r>
+                <a:rPr sz="2000" b="1">
+                  <a:solidFill>
+                    <a:srgbClr val="FFFF00"/>
+                  </a:solidFill>
+                  <a:latin typeface="Microsoft YaHei"/>
+                  <a:ea typeface="Microsoft YaHei"/>
+                  <a:cs typeface="Microsoft YaHei"/>
+                </a:rPr>
+                <a:t>For example</a:t>
+              </a:r>
+            </a:p>
+          </p:txBody>
+        </p:sp>
+      </p:grpSp>
+      <p:sp>
+        <p:nvSpPr>
+          <p:cNvPr id="18" name="TextBox 17"/>
+          <p:cNvSpPr txBox="1"/>
+          <p:nvPr/>
+        </p:nvSpPr>
+        <p:spPr>
+          <a:xfrm>
+            <a:off x="2651760" y="3730752"/>
+            <a:ext cx="7377395" cy="438912"/>
+          </a:xfrm>
+          <a:prstGeom prst="rect">
+            <a:avLst/>
+          </a:prstGeom>
+          <a:noFill/>
+        </p:spPr>
+        <p:txBody>
+          <a:bodyPr wrap="none" lIns="0" rIns="0" anchor="ctr" tIns="0" bIns="0">
+            <a:noAutofit/>
+          </a:bodyPr>
+          <a:lstStyle/>
+          <a:p>
+            <a:pPr>
+              <a:lnSpc>
+                <a:spcPts val="2850"/>
+              </a:lnSpc>
+              <a:spcBef>
+                <a:spcPts val="0"/>
+              </a:spcBef>
+              <a:spcAft>
+                <a:spcPts val="0"/>
+              </a:spcAft>
+            </a:pPr>
+            <a:r>
+              <a:rPr sz="2400" b="0">
+                <a:solidFill>
+                  <a:srgbClr val="101010"/>
+                </a:solidFill>
+                <a:latin typeface="Microsoft YaHei"/>
+                <a:ea typeface="Microsoft YaHei"/>
+                <a:cs typeface="Microsoft YaHei"/>
+              </a:rPr>
+              <a:t>, my classmates and I play in the park at weekends.</a:t>
+            </a:r>
+          </a:p>
+        </p:txBody>
+      </p:sp>
+      <p:sp>
+        <p:nvSpPr>
+          <p:cNvPr id="19" name="TextBox 18"/>
+          <p:cNvSpPr txBox="1"/>
+          <p:nvPr/>
+        </p:nvSpPr>
+        <p:spPr>
+          <a:xfrm>
+            <a:off x="731520" y="4160520"/>
+            <a:ext cx="1689880" cy="438912"/>
+          </a:xfrm>
+          <a:prstGeom prst="rect">
+            <a:avLst/>
+          </a:prstGeom>
+          <a:noFill/>
+        </p:spPr>
+        <p:txBody>
+          <a:bodyPr wrap="none" lIns="0" rIns="0" anchor="ctr" tIns="0" bIns="0">
+            <a:noAutofit/>
+          </a:bodyPr>
+          <a:lstStyle/>
+          <a:p>
+            <a:pPr>
+              <a:lnSpc>
+                <a:spcPts val="2850"/>
+              </a:lnSpc>
+              <a:spcBef>
+                <a:spcPts val="0"/>
+              </a:spcBef>
+              <a:spcAft>
+                <a:spcPts val="0"/>
+              </a:spcAft>
+            </a:pPr>
+            <a:r>
+              <a:rPr sz="2400" b="0">
+                <a:solidFill>
+                  <a:srgbClr val="101010"/>
+                </a:solidFill>
+                <a:latin typeface="Microsoft YaHei"/>
+                <a:ea typeface="Microsoft YaHei"/>
+                <a:cs typeface="Microsoft YaHei"/>
+              </a:rPr>
+              <a:t>We enjoy it </a:t>
+            </a:r>
+          </a:p>
+        </p:txBody>
+      </p:sp>
+      <p:cxnSp>
+        <p:nvCxnSpPr>
+          <p:cNvPr id="20" name="Connector 19"/>
+          <p:cNvCxnSpPr/>
+          <p:nvPr/>
+        </p:nvCxnSpPr>
+        <p:spPr>
+          <a:xfrm>
+            <a:off x="2407684" y="4530852"/>
+            <a:ext cx="1371600" cy="0"/>
+          </a:xfrm>
+          <a:prstGeom prst="line">
+            <a:avLst/>
+          </a:prstGeom>
+          <a:ln w="10795">
+            <a:solidFill>
+              <a:srgbClr val="17365D"/>
+            </a:solidFill>
+          </a:ln>
+        </p:spPr>
+        <p:style>
+          <a:lnRef idx="2">
+            <a:schemeClr val="accent1"/>
+          </a:lnRef>
+          <a:fillRef idx="0">
+            <a:schemeClr val="accent1"/>
+          </a:fillRef>
+          <a:effectRef idx="1">
+            <a:schemeClr val="accent1"/>
+          </a:effectRef>
+          <a:fontRef idx="minor">
+            <a:schemeClr val="tx1"/>
+          </a:fontRef>
+        </p:style>
+      </p:cxnSp>
+      <p:grpSp>
+        <p:nvGrpSpPr>
+          <p:cNvPr id="21" name="Group 20"/>
+          <p:cNvGrpSpPr/>
+          <p:nvPr/>
+        </p:nvGrpSpPr>
+        <p:grpSpPr>
+          <a:xfrm>
+            <a:off x="2384824" y="4176979"/>
+            <a:ext cx="1417320" cy="411480"/>
+            <a:chOff x="2384824" y="4176979"/>
+            <a:chExt cx="1417320" cy="411480"/>
+          </a:xfrm>
+        </p:grpSpPr>
+        <p:sp>
+          <p:nvSpPr>
+            <p:cNvPr id="22" name="Rounded Rectangle 21"/>
+            <p:cNvSpPr/>
+            <p:nvPr/>
+          </p:nvSpPr>
+          <p:spPr>
+            <a:xfrm>
+              <a:off x="2384824" y="4183380"/>
+              <a:ext cx="1417320" cy="393192"/>
+            </a:xfrm>
+            <a:prstGeom prst="roundRect">
+              <a:avLst>
+                <a:gd name="adj" fmla="val 8000"/>
+              </a:avLst>
+            </a:prstGeom>
+            <a:solidFill>
+              <a:srgbClr val="718B2E"/>
+            </a:solidFill>
+            <a:ln w="10160">
+              <a:solidFill>
+                <a:srgbClr val="6B95B6"/>
+              </a:solidFill>
+            </a:ln>
+            <a:effectLst>
+              <a:outerShdw blurRad="25400" dist="19050" dir="5400000" algn="ctr" rotWithShape="0">
+                <a:srgbClr val="000000">
+                  <a:alpha val="22000"/>
+                </a:srgbClr>
+              </a:outerShdw>
+            </a:effectLst>
+          </p:spPr>
+          <p:style>
+            <a:lnRef idx="1">
+              <a:schemeClr val="accent1"/>
+            </a:lnRef>
+            <a:fillRef idx="3">
+              <a:schemeClr val="accent1"/>
+            </a:fillRef>
+            <a:effectRef idx="2">
+              <a:schemeClr val="accent1"/>
+            </a:effectRef>
+            <a:fontRef idx="minor">
+              <a:schemeClr val="lt1"/>
+            </a:fontRef>
+          </p:style>
+          <p:txBody>
+            <a:bodyPr rtlCol="0" anchor="ctr"/>
+            <a:lstStyle/>
+            <a:p>
+              <a:pPr algn="ctr"/>
+            </a:p>
+          </p:txBody>
+        </p:sp>
+        <p:sp>
+          <p:nvSpPr>
+            <p:cNvPr id="23" name="TextBox 22"/>
+            <p:cNvSpPr txBox="1"/>
+            <p:nvPr/>
+          </p:nvSpPr>
+          <p:spPr>
+            <a:xfrm>
+              <a:off x="2398540" y="4176979"/>
+              <a:ext cx="1389888" cy="411480"/>
+            </a:xfrm>
+            <a:prstGeom prst="rect">
+              <a:avLst/>
+            </a:prstGeom>
+            <a:noFill/>
+          </p:spPr>
+          <p:txBody>
+            <a:bodyPr wrap="square" lIns="0" rIns="0" anchor="ctr" tIns="0" bIns="0">
+              <a:spAutoFit/>
+            </a:bodyPr>
+            <a:lstStyle/>
+            <a:p>
+              <a:pPr algn="ctr">
+                <a:lnSpc>
+                  <a:spcPts val="2400"/>
+                </a:lnSpc>
+                <a:spcBef>
+                  <a:spcPts val="0"/>
+                </a:spcBef>
+                <a:spcAft>
+                  <a:spcPts val="0"/>
+                </a:spcAft>
+              </a:pPr>
+              <a:r>
+                <a:rPr sz="2000" b="1">
+                  <a:solidFill>
+                    <a:srgbClr val="FFFF00"/>
+                  </a:solidFill>
+                  <a:latin typeface="Microsoft YaHei"/>
+                  <a:ea typeface="Microsoft YaHei"/>
+                  <a:cs typeface="Microsoft YaHei"/>
+                </a:rPr>
+                <a:t>because</a:t>
+              </a:r>
+            </a:p>
+          </p:txBody>
+        </p:sp>
+      </p:grpSp>
+      <p:sp>
+        <p:nvSpPr>
+          <p:cNvPr id="24" name="TextBox 23"/>
+          <p:cNvSpPr txBox="1"/>
+          <p:nvPr/>
+        </p:nvSpPr>
+        <p:spPr>
+          <a:xfrm>
+            <a:off x="3802144" y="4160520"/>
+            <a:ext cx="5319632" cy="438912"/>
+          </a:xfrm>
+          <a:prstGeom prst="rect">
+            <a:avLst/>
+          </a:prstGeom>
+          <a:noFill/>
+        </p:spPr>
+        <p:txBody>
+          <a:bodyPr wrap="none" lIns="0" rIns="0" anchor="ctr" tIns="0" bIns="0">
+            <a:noAutofit/>
+          </a:bodyPr>
+          <a:lstStyle/>
+          <a:p>
+            <a:pPr>
+              <a:lnSpc>
+                <a:spcPts val="2850"/>
+              </a:lnSpc>
+              <a:spcBef>
+                <a:spcPts val="0"/>
+              </a:spcBef>
+              <a:spcAft>
+                <a:spcPts val="0"/>
+              </a:spcAft>
+            </a:pPr>
+            <a:r>
+              <a:rPr sz="2400" b="0">
+                <a:solidFill>
+                  <a:srgbClr val="101010"/>
+                </a:solidFill>
+                <a:latin typeface="Microsoft YaHei"/>
+                <a:ea typeface="Microsoft YaHei"/>
+                <a:cs typeface="Microsoft YaHei"/>
+              </a:rPr>
+              <a:t> we can laugh and have fun together.</a:t>
+            </a:r>
+          </a:p>
+        </p:txBody>
+      </p:sp>
+      <p:sp>
+        <p:nvSpPr>
+          <p:cNvPr id="25" name="TextBox 24"/>
+          <p:cNvSpPr txBox="1"/>
+          <p:nvPr/>
+        </p:nvSpPr>
+        <p:spPr>
+          <a:xfrm>
+            <a:off x="731520" y="4590288"/>
+            <a:ext cx="615103" cy="438912"/>
+          </a:xfrm>
+          <a:prstGeom prst="rect">
+            <a:avLst/>
+          </a:prstGeom>
+          <a:noFill/>
+        </p:spPr>
+        <p:txBody>
+          <a:bodyPr wrap="none" lIns="0" rIns="0" anchor="ctr" tIns="0" bIns="0">
+            <a:noAutofit/>
+          </a:bodyPr>
+          <a:lstStyle/>
+          <a:p>
+            <a:pPr>
+              <a:lnSpc>
+                <a:spcPts val="2850"/>
+              </a:lnSpc>
+              <a:spcBef>
+                <a:spcPts val="0"/>
+              </a:spcBef>
+              <a:spcAft>
+                <a:spcPts val="0"/>
+              </a:spcAft>
+            </a:pPr>
+            <a:r>
+              <a:rPr sz="2400" b="0">
+                <a:solidFill>
+                  <a:srgbClr val="101010"/>
+                </a:solidFill>
+                <a:latin typeface="Microsoft YaHei"/>
+                <a:ea typeface="Microsoft YaHei"/>
+                <a:cs typeface="Microsoft YaHei"/>
+              </a:rPr>
+              <a:t>It is </a:t>
+            </a:r>
+          </a:p>
+        </p:txBody>
+      </p:sp>
+      <p:cxnSp>
+        <p:nvCxnSpPr>
+          <p:cNvPr id="26" name="Connector 25"/>
+          <p:cNvCxnSpPr/>
+          <p:nvPr/>
+        </p:nvCxnSpPr>
+        <p:spPr>
+          <a:xfrm>
+            <a:off x="1332907" y="4960620"/>
+            <a:ext cx="777240" cy="0"/>
+          </a:xfrm>
+          <a:prstGeom prst="line">
+            <a:avLst/>
+          </a:prstGeom>
+          <a:ln w="10795">
+            <a:solidFill>
+              <a:srgbClr val="17365D"/>
+            </a:solidFill>
+          </a:ln>
+        </p:spPr>
+        <p:style>
+          <a:lnRef idx="2">
+            <a:schemeClr val="accent1"/>
+          </a:lnRef>
+          <a:fillRef idx="0">
+            <a:schemeClr val="accent1"/>
+          </a:fillRef>
+          <a:effectRef idx="1">
+            <a:schemeClr val="accent1"/>
+          </a:effectRef>
+          <a:fontRef idx="minor">
+            <a:schemeClr val="tx1"/>
+          </a:fontRef>
+        </p:style>
+      </p:cxnSp>
+      <p:grpSp>
+        <p:nvGrpSpPr>
+          <p:cNvPr id="27" name="Group 26"/>
+          <p:cNvGrpSpPr/>
+          <p:nvPr/>
+        </p:nvGrpSpPr>
+        <p:grpSpPr>
+          <a:xfrm>
+            <a:off x="1310047" y="4606747"/>
+            <a:ext cx="822960" cy="411480"/>
+            <a:chOff x="1310047" y="4606747"/>
+            <a:chExt cx="822960" cy="411480"/>
+          </a:xfrm>
+        </p:grpSpPr>
+        <p:sp>
+          <p:nvSpPr>
+            <p:cNvPr id="28" name="Rounded Rectangle 27"/>
+            <p:cNvSpPr/>
+            <p:nvPr/>
+          </p:nvSpPr>
+          <p:spPr>
+            <a:xfrm>
+              <a:off x="1310047" y="4613148"/>
+              <a:ext cx="822960" cy="393192"/>
+            </a:xfrm>
+            <a:prstGeom prst="roundRect">
+              <a:avLst>
+                <a:gd name="adj" fmla="val 8000"/>
+              </a:avLst>
+            </a:prstGeom>
+            <a:solidFill>
+              <a:srgbClr val="718B2E"/>
+            </a:solidFill>
+            <a:ln w="10160">
+              <a:solidFill>
+                <a:srgbClr val="6B95B6"/>
+              </a:solidFill>
+            </a:ln>
+            <a:effectLst>
+              <a:outerShdw blurRad="25400" dist="19050" dir="5400000" algn="ctr" rotWithShape="0">
+                <a:srgbClr val="000000">
+                  <a:alpha val="22000"/>
+                </a:srgbClr>
+              </a:outerShdw>
+            </a:effectLst>
+          </p:spPr>
+          <p:style>
+            <a:lnRef idx="1">
+              <a:schemeClr val="accent1"/>
+            </a:lnRef>
+            <a:fillRef idx="3">
+              <a:schemeClr val="accent1"/>
+            </a:fillRef>
+            <a:effectRef idx="2">
+              <a:schemeClr val="accent1"/>
+            </a:effectRef>
+            <a:fontRef idx="minor">
+              <a:schemeClr val="lt1"/>
+            </a:fontRef>
+          </p:style>
+          <p:txBody>
+            <a:bodyPr rtlCol="0" anchor="ctr"/>
+            <a:lstStyle/>
+            <a:p>
+              <a:pPr algn="ctr"/>
+            </a:p>
+          </p:txBody>
+        </p:sp>
+        <p:sp>
+          <p:nvSpPr>
+            <p:cNvPr id="29" name="TextBox 28"/>
+            <p:cNvSpPr txBox="1"/>
+            <p:nvPr/>
+          </p:nvSpPr>
+          <p:spPr>
+            <a:xfrm>
+              <a:off x="1323763" y="4606747"/>
+              <a:ext cx="795528" cy="411480"/>
+            </a:xfrm>
+            <a:prstGeom prst="rect">
+              <a:avLst/>
+            </a:prstGeom>
+            <a:noFill/>
+          </p:spPr>
+          <p:txBody>
+            <a:bodyPr wrap="square" lIns="0" rIns="0" anchor="ctr" tIns="0" bIns="0">
+              <a:spAutoFit/>
+            </a:bodyPr>
+            <a:lstStyle/>
+            <a:p>
+              <a:pPr algn="ctr">
+                <a:lnSpc>
+                  <a:spcPts val="2400"/>
+                </a:lnSpc>
+                <a:spcBef>
+                  <a:spcPts val="0"/>
+                </a:spcBef>
+                <a:spcAft>
+                  <a:spcPts val="0"/>
+                </a:spcAft>
+              </a:pPr>
+              <a:r>
+                <a:rPr sz="2000" b="1">
+                  <a:solidFill>
+                    <a:srgbClr val="FFFF00"/>
+                  </a:solidFill>
+                  <a:latin typeface="Microsoft YaHei"/>
+                  <a:ea typeface="Microsoft YaHei"/>
+                  <a:cs typeface="Microsoft YaHei"/>
+                </a:rPr>
+                <a:t>also</a:t>
+              </a:r>
+            </a:p>
+          </p:txBody>
+        </p:sp>
+      </p:grpSp>
+      <p:sp>
+        <p:nvSpPr>
+          <p:cNvPr id="30" name="TextBox 29"/>
+          <p:cNvSpPr txBox="1"/>
+          <p:nvPr/>
+        </p:nvSpPr>
+        <p:spPr>
+          <a:xfrm>
+            <a:off x="2133007" y="4590288"/>
+            <a:ext cx="2015653" cy="438912"/>
+          </a:xfrm>
+          <a:prstGeom prst="rect">
+            <a:avLst/>
+          </a:prstGeom>
+          <a:noFill/>
+        </p:spPr>
+        <p:txBody>
+          <a:bodyPr wrap="none" lIns="0" rIns="0" anchor="ctr" tIns="0" bIns="0">
+            <a:noAutofit/>
+          </a:bodyPr>
+          <a:lstStyle/>
+          <a:p>
+            <a:pPr>
+              <a:lnSpc>
+                <a:spcPts val="2850"/>
+              </a:lnSpc>
+              <a:spcBef>
+                <a:spcPts val="0"/>
+              </a:spcBef>
+              <a:spcAft>
+                <a:spcPts val="0"/>
+              </a:spcAft>
+            </a:pPr>
+            <a:r>
+              <a:rPr sz="2400" b="0">
+                <a:solidFill>
+                  <a:srgbClr val="101010"/>
+                </a:solidFill>
+                <a:latin typeface="Microsoft YaHei"/>
+                <a:ea typeface="Microsoft YaHei"/>
+                <a:cs typeface="Microsoft YaHei"/>
+              </a:rPr>
+              <a:t> easy to start. </a:t>
+            </a:r>
+          </a:p>
+        </p:txBody>
+      </p:sp>
+      <p:cxnSp>
+        <p:nvCxnSpPr>
+          <p:cNvPr id="31" name="Connector 30"/>
+          <p:cNvCxnSpPr/>
+          <p:nvPr/>
+        </p:nvCxnSpPr>
+        <p:spPr>
+          <a:xfrm>
+            <a:off x="4134945" y="4960620"/>
+            <a:ext cx="1874520" cy="0"/>
+          </a:xfrm>
+          <a:prstGeom prst="line">
+            <a:avLst/>
+          </a:prstGeom>
+          <a:ln w="10795">
+            <a:solidFill>
+              <a:srgbClr val="17365D"/>
+            </a:solidFill>
+          </a:ln>
+        </p:spPr>
+        <p:style>
+          <a:lnRef idx="2">
+            <a:schemeClr val="accent1"/>
+          </a:lnRef>
+          <a:fillRef idx="0">
+            <a:schemeClr val="accent1"/>
+          </a:fillRef>
+          <a:effectRef idx="1">
+            <a:schemeClr val="accent1"/>
+          </a:effectRef>
+          <a:fontRef idx="minor">
+            <a:schemeClr val="tx1"/>
+          </a:fontRef>
+        </p:style>
+      </p:cxnSp>
+      <p:grpSp>
+        <p:nvGrpSpPr>
+          <p:cNvPr id="32" name="Group 31"/>
+          <p:cNvGrpSpPr/>
+          <p:nvPr/>
+        </p:nvGrpSpPr>
+        <p:grpSpPr>
+          <a:xfrm>
+            <a:off x="4112085" y="4606747"/>
+            <a:ext cx="1920240" cy="411480"/>
+            <a:chOff x="4112085" y="4606747"/>
+            <a:chExt cx="1920240" cy="411480"/>
+          </a:xfrm>
+        </p:grpSpPr>
+        <p:sp>
+          <p:nvSpPr>
+            <p:cNvPr id="33" name="Rounded Rectangle 32"/>
+            <p:cNvSpPr/>
+            <p:nvPr/>
+          </p:nvSpPr>
+          <p:spPr>
+            <a:xfrm>
+              <a:off x="4112085" y="4613148"/>
+              <a:ext cx="1920240" cy="393192"/>
+            </a:xfrm>
+            <a:prstGeom prst="roundRect">
+              <a:avLst>
+                <a:gd name="adj" fmla="val 8000"/>
+              </a:avLst>
+            </a:prstGeom>
+            <a:solidFill>
+              <a:srgbClr val="718B2E"/>
+            </a:solidFill>
+            <a:ln w="10160">
+              <a:solidFill>
+                <a:srgbClr val="6B95B6"/>
+              </a:solidFill>
+            </a:ln>
+            <a:effectLst>
+              <a:outerShdw blurRad="25400" dist="19050" dir="5400000" algn="ctr" rotWithShape="0">
+                <a:srgbClr val="000000">
+                  <a:alpha val="22000"/>
+                </a:srgbClr>
+              </a:outerShdw>
+            </a:effectLst>
+          </p:spPr>
+          <p:style>
+            <a:lnRef idx="1">
+              <a:schemeClr val="accent1"/>
+            </a:lnRef>
+            <a:fillRef idx="3">
+              <a:schemeClr val="accent1"/>
+            </a:fillRef>
+            <a:effectRef idx="2">
+              <a:schemeClr val="accent1"/>
+            </a:effectRef>
+            <a:fontRef idx="minor">
+              <a:schemeClr val="lt1"/>
+            </a:fontRef>
+          </p:style>
+          <p:txBody>
+            <a:bodyPr rtlCol="0" anchor="ctr"/>
+            <a:lstStyle/>
+            <a:p>
+              <a:pPr algn="ctr"/>
+            </a:p>
+          </p:txBody>
+        </p:sp>
+        <p:sp>
+          <p:nvSpPr>
+            <p:cNvPr id="34" name="TextBox 33"/>
+            <p:cNvSpPr txBox="1"/>
+            <p:nvPr/>
+          </p:nvSpPr>
+          <p:spPr>
+            <a:xfrm>
+              <a:off x="4125801" y="4606747"/>
+              <a:ext cx="1892808" cy="411480"/>
+            </a:xfrm>
+            <a:prstGeom prst="rect">
+              <a:avLst/>
+            </a:prstGeom>
+            <a:noFill/>
+          </p:spPr>
+          <p:txBody>
+            <a:bodyPr wrap="square" lIns="0" rIns="0" anchor="ctr" tIns="0" bIns="0">
+              <a:spAutoFit/>
+            </a:bodyPr>
+            <a:lstStyle/>
+            <a:p>
+              <a:pPr algn="ctr">
+                <a:lnSpc>
+                  <a:spcPts val="2400"/>
+                </a:lnSpc>
+                <a:spcBef>
+                  <a:spcPts val="0"/>
+                </a:spcBef>
+                <a:spcAft>
+                  <a:spcPts val="0"/>
+                </a:spcAft>
+              </a:pPr>
+              <a:r>
+                <a:rPr sz="2000" b="1">
+                  <a:solidFill>
+                    <a:srgbClr val="FFFF00"/>
+                  </a:solidFill>
+                  <a:latin typeface="Microsoft YaHei"/>
+                  <a:ea typeface="Microsoft YaHei"/>
+                  <a:cs typeface="Microsoft YaHei"/>
+                </a:rPr>
+                <a:t>For instance</a:t>
+              </a:r>
+            </a:p>
+          </p:txBody>
+        </p:sp>
+      </p:grpSp>
+      <p:sp>
+        <p:nvSpPr>
+          <p:cNvPr id="35" name="TextBox 34"/>
+          <p:cNvSpPr txBox="1"/>
+          <p:nvPr/>
+        </p:nvSpPr>
+        <p:spPr>
+          <a:xfrm>
+            <a:off x="6032325" y="4590288"/>
+            <a:ext cx="3077982" cy="438912"/>
+          </a:xfrm>
+          <a:prstGeom prst="rect">
+            <a:avLst/>
+          </a:prstGeom>
+          <a:noFill/>
+        </p:spPr>
+        <p:txBody>
+          <a:bodyPr wrap="none" lIns="0" rIns="0" anchor="ctr" tIns="0" bIns="0">
+            <a:noAutofit/>
+          </a:bodyPr>
+          <a:lstStyle/>
+          <a:p>
+            <a:pPr>
+              <a:lnSpc>
+                <a:spcPts val="2850"/>
+              </a:lnSpc>
+              <a:spcBef>
+                <a:spcPts val="0"/>
+              </a:spcBef>
+              <a:spcAft>
+                <a:spcPts val="0"/>
+              </a:spcAft>
+            </a:pPr>
+            <a:r>
+              <a:rPr sz="2400" b="0">
+                <a:solidFill>
+                  <a:srgbClr val="101010"/>
+                </a:solidFill>
+                <a:latin typeface="Microsoft YaHei"/>
+                <a:ea typeface="Microsoft YaHei"/>
+                <a:cs typeface="Microsoft YaHei"/>
+              </a:rPr>
+              <a:t>, you only need a ball</a:t>
+            </a:r>
+          </a:p>
+        </p:txBody>
+      </p:sp>
+      <p:sp>
+        <p:nvSpPr>
+          <p:cNvPr id="36" name="TextBox 35"/>
+          <p:cNvSpPr txBox="1"/>
+          <p:nvPr/>
+        </p:nvSpPr>
+        <p:spPr>
+          <a:xfrm>
+            <a:off x="731520" y="5020056"/>
+            <a:ext cx="6653944" cy="438912"/>
+          </a:xfrm>
+          <a:prstGeom prst="rect">
+            <a:avLst/>
+          </a:prstGeom>
+          <a:noFill/>
+        </p:spPr>
+        <p:txBody>
+          <a:bodyPr wrap="none" lIns="0" rIns="0" anchor="ctr" tIns="0" bIns="0">
+            <a:noAutofit/>
+          </a:bodyPr>
+          <a:lstStyle/>
+          <a:p>
+            <a:pPr>
+              <a:lnSpc>
+                <a:spcPts val="2850"/>
+              </a:lnSpc>
+              <a:spcBef>
+                <a:spcPts val="0"/>
+              </a:spcBef>
+              <a:spcAft>
+                <a:spcPts val="0"/>
+              </a:spcAft>
+            </a:pPr>
+            <a:r>
+              <a:rPr sz="2400" b="0">
+                <a:solidFill>
+                  <a:srgbClr val="101010"/>
+                </a:solidFill>
+                <a:latin typeface="Microsoft YaHei"/>
+                <a:ea typeface="Microsoft YaHei"/>
+                <a:cs typeface="Microsoft YaHei"/>
+              </a:rPr>
+              <a:t>and a court. There are courts near our school, </a:t>
+            </a:r>
+          </a:p>
+        </p:txBody>
+      </p:sp>
+      <p:cxnSp>
+        <p:nvCxnSpPr>
+          <p:cNvPr id="37" name="Connector 36"/>
+          <p:cNvCxnSpPr/>
+          <p:nvPr/>
+        </p:nvCxnSpPr>
+        <p:spPr>
+          <a:xfrm>
+            <a:off x="7371748" y="5390388"/>
+            <a:ext cx="548640" cy="0"/>
+          </a:xfrm>
+          <a:prstGeom prst="line">
+            <a:avLst/>
+          </a:prstGeom>
+          <a:ln w="10795">
+            <a:solidFill>
+              <a:srgbClr val="17365D"/>
+            </a:solidFill>
+          </a:ln>
+        </p:spPr>
+        <p:style>
+          <a:lnRef idx="2">
+            <a:schemeClr val="accent1"/>
+          </a:lnRef>
+          <a:fillRef idx="0">
+            <a:schemeClr val="accent1"/>
+          </a:fillRef>
+          <a:effectRef idx="1">
+            <a:schemeClr val="accent1"/>
+          </a:effectRef>
+          <a:fontRef idx="minor">
+            <a:schemeClr val="tx1"/>
+          </a:fontRef>
+        </p:style>
+      </p:cxnSp>
+      <p:grpSp>
+        <p:nvGrpSpPr>
+          <p:cNvPr id="38" name="Group 37"/>
+          <p:cNvGrpSpPr/>
+          <p:nvPr/>
+        </p:nvGrpSpPr>
+        <p:grpSpPr>
+          <a:xfrm>
+            <a:off x="7348888" y="5036515"/>
+            <a:ext cx="594360" cy="411480"/>
+            <a:chOff x="7348888" y="5036515"/>
+            <a:chExt cx="594360" cy="411480"/>
+          </a:xfrm>
+        </p:grpSpPr>
+        <p:sp>
+          <p:nvSpPr>
+            <p:cNvPr id="39" name="Rounded Rectangle 38"/>
+            <p:cNvSpPr/>
+            <p:nvPr/>
+          </p:nvSpPr>
+          <p:spPr>
+            <a:xfrm>
+              <a:off x="7348888" y="5042916"/>
+              <a:ext cx="594360" cy="393192"/>
+            </a:xfrm>
+            <a:prstGeom prst="roundRect">
+              <a:avLst>
+                <a:gd name="adj" fmla="val 8000"/>
+              </a:avLst>
+            </a:prstGeom>
+            <a:solidFill>
+              <a:srgbClr val="718B2E"/>
+            </a:solidFill>
+            <a:ln w="10160">
+              <a:solidFill>
+                <a:srgbClr val="6B95B6"/>
+              </a:solidFill>
+            </a:ln>
+            <a:effectLst>
+              <a:outerShdw blurRad="25400" dist="19050" dir="5400000" algn="ctr" rotWithShape="0">
+                <a:srgbClr val="000000">
+                  <a:alpha val="22000"/>
+                </a:srgbClr>
+              </a:outerShdw>
+            </a:effectLst>
+          </p:spPr>
+          <p:style>
+            <a:lnRef idx="1">
+              <a:schemeClr val="accent1"/>
+            </a:lnRef>
+            <a:fillRef idx="3">
+              <a:schemeClr val="accent1"/>
+            </a:fillRef>
+            <a:effectRef idx="2">
+              <a:schemeClr val="accent1"/>
+            </a:effectRef>
+            <a:fontRef idx="minor">
+              <a:schemeClr val="lt1"/>
+            </a:fontRef>
+          </p:style>
+          <p:txBody>
+            <a:bodyPr rtlCol="0" anchor="ctr"/>
+            <a:lstStyle/>
+            <a:p>
+              <a:pPr algn="ctr"/>
+            </a:p>
+          </p:txBody>
+        </p:sp>
+        <p:sp>
+          <p:nvSpPr>
+            <p:cNvPr id="40" name="TextBox 39"/>
+            <p:cNvSpPr txBox="1"/>
+            <p:nvPr/>
+          </p:nvSpPr>
+          <p:spPr>
+            <a:xfrm>
+              <a:off x="7362604" y="5036515"/>
+              <a:ext cx="566928" cy="411480"/>
+            </a:xfrm>
+            <a:prstGeom prst="rect">
+              <a:avLst/>
+            </a:prstGeom>
+            <a:noFill/>
+          </p:spPr>
+          <p:txBody>
+            <a:bodyPr wrap="square" lIns="0" rIns="0" anchor="ctr" tIns="0" bIns="0">
+              <a:spAutoFit/>
+            </a:bodyPr>
+            <a:lstStyle/>
+            <a:p>
+              <a:pPr algn="ctr">
+                <a:lnSpc>
+                  <a:spcPts val="2400"/>
+                </a:lnSpc>
+                <a:spcBef>
+                  <a:spcPts val="0"/>
+                </a:spcBef>
+                <a:spcAft>
+                  <a:spcPts val="0"/>
+                </a:spcAft>
+              </a:pPr>
+              <a:r>
+                <a:rPr sz="2000" b="1">
+                  <a:solidFill>
+                    <a:srgbClr val="FFFF00"/>
+                  </a:solidFill>
+                  <a:latin typeface="Microsoft YaHei"/>
+                  <a:ea typeface="Microsoft YaHei"/>
+                  <a:cs typeface="Microsoft YaHei"/>
+                </a:rPr>
+                <a:t>so</a:t>
+              </a:r>
+            </a:p>
+          </p:txBody>
+        </p:sp>
+      </p:grpSp>
+      <p:sp>
+        <p:nvSpPr>
+          <p:cNvPr id="41" name="TextBox 40"/>
+          <p:cNvSpPr txBox="1"/>
+          <p:nvPr/>
+        </p:nvSpPr>
+        <p:spPr>
+          <a:xfrm>
+            <a:off x="7943248" y="5020056"/>
+            <a:ext cx="3423591" cy="438912"/>
+          </a:xfrm>
+          <a:prstGeom prst="rect">
+            <a:avLst/>
+          </a:prstGeom>
+          <a:noFill/>
+        </p:spPr>
+        <p:txBody>
+          <a:bodyPr wrap="none" lIns="0" rIns="0" anchor="ctr" tIns="0" bIns="0">
+            <a:noAutofit/>
+          </a:bodyPr>
+          <a:lstStyle/>
+          <a:p>
+            <a:pPr>
+              <a:lnSpc>
+                <a:spcPts val="2850"/>
+              </a:lnSpc>
+              <a:spcBef>
+                <a:spcPts val="0"/>
+              </a:spcBef>
+              <a:spcAft>
+                <a:spcPts val="0"/>
+              </a:spcAft>
+            </a:pPr>
+            <a:r>
+              <a:rPr sz="2400" b="0">
+                <a:solidFill>
+                  <a:srgbClr val="101010"/>
+                </a:solidFill>
+                <a:latin typeface="Microsoft YaHei"/>
+                <a:ea typeface="Microsoft YaHei"/>
+                <a:cs typeface="Microsoft YaHei"/>
+              </a:rPr>
+              <a:t> we can play after class.</a:t>
+            </a:r>
+          </a:p>
+        </p:txBody>
+      </p:sp>
+      <p:cxnSp>
+        <p:nvCxnSpPr>
+          <p:cNvPr id="42" name="Connector 41"/>
+          <p:cNvCxnSpPr/>
+          <p:nvPr/>
+        </p:nvCxnSpPr>
+        <p:spPr>
+          <a:xfrm>
+            <a:off x="754380" y="5820156"/>
+            <a:ext cx="1188720" cy="0"/>
+          </a:xfrm>
+          <a:prstGeom prst="line">
+            <a:avLst/>
+          </a:prstGeom>
+          <a:ln w="10795">
+            <a:solidFill>
+              <a:srgbClr val="17365D"/>
+            </a:solidFill>
+          </a:ln>
+        </p:spPr>
+        <p:style>
+          <a:lnRef idx="2">
+            <a:schemeClr val="accent1"/>
+          </a:lnRef>
+          <a:fillRef idx="0">
+            <a:schemeClr val="accent1"/>
+          </a:fillRef>
+          <a:effectRef idx="1">
+            <a:schemeClr val="accent1"/>
+          </a:effectRef>
+          <a:fontRef idx="minor">
+            <a:schemeClr val="tx1"/>
+          </a:fontRef>
+        </p:style>
+      </p:cxnSp>
+      <p:grpSp>
+        <p:nvGrpSpPr>
+          <p:cNvPr id="43" name="Group 42"/>
+          <p:cNvGrpSpPr/>
+          <p:nvPr/>
+        </p:nvGrpSpPr>
+        <p:grpSpPr>
+          <a:xfrm>
+            <a:off x="731520" y="5466283"/>
+            <a:ext cx="1234440" cy="411480"/>
+            <a:chOff x="731520" y="5466283"/>
+            <a:chExt cx="1234440" cy="411480"/>
+          </a:xfrm>
+        </p:grpSpPr>
+        <p:sp>
+          <p:nvSpPr>
+            <p:cNvPr id="44" name="Rounded Rectangle 43"/>
+            <p:cNvSpPr/>
+            <p:nvPr/>
+          </p:nvSpPr>
+          <p:spPr>
+            <a:xfrm>
+              <a:off x="731520" y="5472684"/>
+              <a:ext cx="1234440" cy="393192"/>
+            </a:xfrm>
+            <a:prstGeom prst="roundRect">
+              <a:avLst>
+                <a:gd name="adj" fmla="val 8000"/>
+              </a:avLst>
+            </a:prstGeom>
+            <a:solidFill>
+              <a:srgbClr val="718B2E"/>
+            </a:solidFill>
+            <a:ln w="10160">
+              <a:solidFill>
+                <a:srgbClr val="6B95B6"/>
+              </a:solidFill>
+            </a:ln>
+            <a:effectLst>
+              <a:outerShdw blurRad="25400" dist="19050" dir="5400000" algn="ctr" rotWithShape="0">
+                <a:srgbClr val="000000">
+                  <a:alpha val="22000"/>
+                </a:srgbClr>
+              </a:outerShdw>
+            </a:effectLst>
+          </p:spPr>
+          <p:style>
+            <a:lnRef idx="1">
+              <a:schemeClr val="accent1"/>
+            </a:lnRef>
+            <a:fillRef idx="3">
+              <a:schemeClr val="accent1"/>
+            </a:fillRef>
+            <a:effectRef idx="2">
+              <a:schemeClr val="accent1"/>
+            </a:effectRef>
+            <a:fontRef idx="minor">
+              <a:schemeClr val="lt1"/>
+            </a:fontRef>
+          </p:style>
+          <p:txBody>
+            <a:bodyPr rtlCol="0" anchor="ctr"/>
+            <a:lstStyle/>
+            <a:p>
+              <a:pPr algn="ctr"/>
+            </a:p>
+          </p:txBody>
+        </p:sp>
+        <p:sp>
+          <p:nvSpPr>
+            <p:cNvPr id="45" name="TextBox 44"/>
+            <p:cNvSpPr txBox="1"/>
+            <p:nvPr/>
+          </p:nvSpPr>
+          <p:spPr>
+            <a:xfrm>
+              <a:off x="745236" y="5466283"/>
+              <a:ext cx="1207008" cy="411480"/>
+            </a:xfrm>
+            <a:prstGeom prst="rect">
+              <a:avLst/>
+            </a:prstGeom>
+            <a:noFill/>
+          </p:spPr>
+          <p:txBody>
+            <a:bodyPr wrap="square" lIns="0" rIns="0" anchor="ctr" tIns="0" bIns="0">
+              <a:spAutoFit/>
+            </a:bodyPr>
+            <a:lstStyle/>
+            <a:p>
+              <a:pPr algn="ctr">
+                <a:lnSpc>
+                  <a:spcPts val="2400"/>
+                </a:lnSpc>
+                <a:spcBef>
+                  <a:spcPts val="0"/>
+                </a:spcBef>
+                <a:spcAft>
+                  <a:spcPts val="0"/>
+                </a:spcAft>
+              </a:pPr>
+              <a:r>
+                <a:rPr sz="2000" b="1">
+                  <a:solidFill>
+                    <a:srgbClr val="FFFF00"/>
+                  </a:solidFill>
+                  <a:latin typeface="Microsoft YaHei"/>
+                  <a:ea typeface="Microsoft YaHei"/>
+                  <a:cs typeface="Microsoft YaHei"/>
+                </a:rPr>
+                <a:t>Finally</a:t>
+              </a:r>
+            </a:p>
+          </p:txBody>
+        </p:sp>
+      </p:grpSp>
+      <p:sp>
+        <p:nvSpPr>
+          <p:cNvPr id="46" name="TextBox 45"/>
+          <p:cNvSpPr txBox="1"/>
+          <p:nvPr/>
+        </p:nvSpPr>
+        <p:spPr>
+          <a:xfrm>
+            <a:off x="1965960" y="5449824"/>
+            <a:ext cx="7565430" cy="438912"/>
+          </a:xfrm>
+          <a:prstGeom prst="rect">
+            <a:avLst/>
+          </a:prstGeom>
+          <a:noFill/>
+        </p:spPr>
+        <p:txBody>
+          <a:bodyPr wrap="none" lIns="0" rIns="0" anchor="ctr" tIns="0" bIns="0">
+            <a:noAutofit/>
+          </a:bodyPr>
+          <a:lstStyle/>
+          <a:p>
+            <a:pPr>
+              <a:lnSpc>
+                <a:spcPts val="2850"/>
+              </a:lnSpc>
+              <a:spcBef>
+                <a:spcPts val="0"/>
+              </a:spcBef>
+              <a:spcAft>
+                <a:spcPts val="0"/>
+              </a:spcAft>
+            </a:pPr>
+            <a:r>
+              <a:rPr sz="2400" b="0">
+                <a:solidFill>
+                  <a:srgbClr val="101010"/>
+                </a:solidFill>
+                <a:latin typeface="Microsoft YaHei"/>
+                <a:ea typeface="Microsoft YaHei"/>
+                <a:cs typeface="Microsoft YaHei"/>
+              </a:rPr>
+              <a:t>, a short game helps us relax after a busy school day.</a:t>
+            </a:r>
+          </a:p>
+        </p:txBody>
+      </p:sp>
+      <p:sp>
+        <p:nvSpPr>
+          <p:cNvPr id="47" name="TextBox 46"/>
+          <p:cNvSpPr txBox="1"/>
+          <p:nvPr/>
+        </p:nvSpPr>
+        <p:spPr>
+          <a:xfrm>
+            <a:off x="731520" y="5879592"/>
+            <a:ext cx="4105953" cy="438912"/>
+          </a:xfrm>
+          <a:prstGeom prst="rect">
+            <a:avLst/>
+          </a:prstGeom>
+          <a:noFill/>
+        </p:spPr>
+        <p:txBody>
+          <a:bodyPr wrap="none" lIns="0" rIns="0" anchor="ctr" tIns="0" bIns="0">
+            <a:noAutofit/>
+          </a:bodyPr>
+          <a:lstStyle/>
+          <a:p>
+            <a:pPr>
+              <a:lnSpc>
+                <a:spcPts val="2850"/>
+              </a:lnSpc>
+              <a:spcBef>
+                <a:spcPts val="0"/>
+              </a:spcBef>
+              <a:spcAft>
+                <a:spcPts val="0"/>
+              </a:spcAft>
+            </a:pPr>
+            <a:r>
+              <a:rPr sz="2400" b="0">
+                <a:solidFill>
+                  <a:srgbClr val="101010"/>
+                </a:solidFill>
+                <a:latin typeface="Microsoft YaHei"/>
+                <a:ea typeface="Microsoft YaHei"/>
+                <a:cs typeface="Microsoft YaHei"/>
+              </a:rPr>
+              <a:t>Why not try it this weekend?</a:t>
+            </a:r>
+          </a:p>
+        </p:txBody>
+      </p:sp>
+      <p:sp>
+        <p:nvSpPr>
+          <p:cNvPr id="48" name="Rectangle 47"/>
+          <p:cNvSpPr/>
+          <p:nvPr/>
+        </p:nvSpPr>
+        <p:spPr>
+          <a:xfrm>
+            <a:off x="621792" y="6492240"/>
+            <a:ext cx="10945368" cy="10972"/>
+          </a:xfrm>
+          <a:prstGeom prst="rect">
+            <a:avLst/>
+          </a:prstGeom>
+          <a:solidFill>
+            <a:srgbClr val="CBDCE9"/>
+          </a:solidFill>
+          <a:ln>
+            <a:noFill/>
+          </a:ln>
+        </p:spPr>
+        <p:style>
+          <a:lnRef idx="1">
+            <a:schemeClr val="accent1"/>
+          </a:lnRef>
+          <a:fillRef idx="3">
+            <a:schemeClr val="accent1"/>
+          </a:fillRef>
+          <a:effectRef idx="2">
+            <a:schemeClr val="accent1"/>
+          </a:effectRef>
+          <a:fontRef idx="minor">
+            <a:schemeClr val="lt1"/>
+          </a:fontRef>
+        </p:style>
+        <p:txBody>
+          <a:bodyPr rtlCol="0" anchor="ctr"/>
+          <a:lstStyle/>
+          <a:p>
+            <a:pPr algn="ctr"/>
+          </a:p>
+        </p:txBody>
+      </p:sp>
+      <p:sp>
+        <p:nvSpPr>
+          <p:cNvPr id="49" name="TextBox 48"/>
+          <p:cNvSpPr txBox="1"/>
+          <p:nvPr/>
+        </p:nvSpPr>
+        <p:spPr>
+          <a:xfrm>
+            <a:off x="594360" y="6583680"/>
             <a:ext cx="9144000" cy="192024"/>
           </a:xfrm>
           <a:prstGeom prst="rect">
@@ -6773,13 +8584,13 @@
       </p:sp>
       <p:sp>
         <p:nvSpPr>
-          <p:cNvPr id="7" name="TextBox 6"/>
+          <p:cNvPr id="50" name="TextBox 49"/>
           <p:cNvSpPr txBox="1"/>
           <p:nvPr/>
         </p:nvSpPr>
         <p:spPr>
           <a:xfrm>
-            <a:off x="11045952" y="6473952"/>
+            <a:off x="11045952" y="6547104"/>
             <a:ext cx="475488" cy="265176"/>
           </a:xfrm>
           <a:prstGeom prst="rect">
@@ -6814,366 +8625,6 @@
                 <a:cs typeface="Microsoft YaHei"/>
               </a:rPr>
               <a:t>11</a:t>
-            </a:r>
-          </a:p>
-        </p:txBody>
-      </p:sp>
-      <p:sp>
-        <p:nvSpPr>
-          <p:cNvPr id="8" name="TextBox 7"/>
-          <p:cNvSpPr txBox="1"/>
-          <p:nvPr/>
-        </p:nvSpPr>
-        <p:spPr>
-          <a:xfrm>
-            <a:off x="822960" y="1645920"/>
-            <a:ext cx="10515600" cy="786384"/>
-          </a:xfrm>
-          <a:prstGeom prst="rect">
-            <a:avLst/>
-          </a:prstGeom>
-          <a:solidFill>
-            <a:srgbClr val="EEF5FB"/>
-          </a:solidFill>
-        </p:spPr>
-        <p:txBody>
-          <a:bodyPr wrap="square" lIns="109728" rIns="109728" anchor="ctr">
-            <a:spAutoFit/>
-          </a:bodyPr>
-          <a:lstStyle/>
-          <a:p>
-            <a:pPr>
-              <a:lnSpc>
-                <a:spcPct val="112000"/>
-              </a:lnSpc>
-              <a:spcBef>
-                <a:spcPts val="0"/>
-              </a:spcBef>
-              <a:spcAft>
-                <a:spcPts val="300"/>
-              </a:spcAft>
-            </a:pPr>
-            <a:r>
-              <a:rPr sz="2600" b="0">
-                <a:solidFill>
-                  <a:srgbClr val="203448"/>
-                </a:solidFill>
-                <a:latin typeface="Microsoft YaHei"/>
-                <a:ea typeface="Microsoft YaHei"/>
-                <a:cs typeface="Microsoft YaHei"/>
-              </a:rPr>
-              <a:t>1  Young people enjoy basketball ______</a:t>
-            </a:r>
-          </a:p>
-          <a:p>
-            <a:pPr>
-              <a:lnSpc>
-                <a:spcPct val="112000"/>
-              </a:lnSpc>
-              <a:spcBef>
-                <a:spcPts val="0"/>
-              </a:spcBef>
-              <a:spcAft>
-                <a:spcPts val="300"/>
-              </a:spcAft>
-            </a:pPr>
-            <a:r>
-              <a:rPr sz="2600" b="0">
-                <a:solidFill>
-                  <a:srgbClr val="203448"/>
-                </a:solidFill>
-                <a:latin typeface="Microsoft YaHei"/>
-                <a:ea typeface="Microsoft YaHei"/>
-                <a:cs typeface="Microsoft YaHei"/>
-              </a:rPr>
-              <a:t>    they can play with friends.</a:t>
-            </a:r>
-          </a:p>
-        </p:txBody>
-      </p:sp>
-      <p:sp>
-        <p:nvSpPr>
-          <p:cNvPr id="9" name="TextBox 8"/>
-          <p:cNvSpPr txBox="1"/>
-          <p:nvPr/>
-        </p:nvSpPr>
-        <p:spPr>
-          <a:xfrm>
-            <a:off x="1042415" y="2459736"/>
-            <a:ext cx="9966960" cy="438912"/>
-          </a:xfrm>
-          <a:prstGeom prst="rect">
-            <a:avLst/>
-          </a:prstGeom>
-          <a:noFill/>
-        </p:spPr>
-        <p:txBody>
-          <a:bodyPr wrap="square" lIns="109728" rIns="109728" anchor="ctr">
-            <a:spAutoFit/>
-          </a:bodyPr>
-          <a:lstStyle/>
-          <a:p>
-            <a:pPr>
-              <a:lnSpc>
-                <a:spcPct val="112000"/>
-              </a:lnSpc>
-              <a:spcBef>
-                <a:spcPts val="0"/>
-              </a:spcBef>
-              <a:spcAft>
-                <a:spcPts val="300"/>
-              </a:spcAft>
-            </a:pPr>
-            <a:r>
-              <a:rPr sz="2400" b="1">
-                <a:solidFill>
-                  <a:srgbClr val="30776D"/>
-                </a:solidFill>
-                <a:latin typeface="Microsoft YaHei"/>
-                <a:ea typeface="Microsoft YaHei"/>
-                <a:cs typeface="Microsoft YaHei"/>
-              </a:rPr>
-              <a:t>because</a:t>
-            </a:r>
-          </a:p>
-        </p:txBody>
-      </p:sp>
-      <p:sp>
-        <p:nvSpPr>
-          <p:cNvPr id="10" name="TextBox 9"/>
-          <p:cNvSpPr txBox="1"/>
-          <p:nvPr/>
-        </p:nvSpPr>
-        <p:spPr>
-          <a:xfrm>
-            <a:off x="822960" y="3035808"/>
-            <a:ext cx="10515600" cy="786384"/>
-          </a:xfrm>
-          <a:prstGeom prst="rect">
-            <a:avLst/>
-          </a:prstGeom>
-          <a:solidFill>
-            <a:srgbClr val="EEF5FB"/>
-          </a:solidFill>
-        </p:spPr>
-        <p:txBody>
-          <a:bodyPr wrap="square" lIns="109728" rIns="109728" anchor="ctr">
-            <a:spAutoFit/>
-          </a:bodyPr>
-          <a:lstStyle/>
-          <a:p>
-            <a:pPr>
-              <a:lnSpc>
-                <a:spcPct val="112000"/>
-              </a:lnSpc>
-              <a:spcBef>
-                <a:spcPts val="0"/>
-              </a:spcBef>
-              <a:spcAft>
-                <a:spcPts val="300"/>
-              </a:spcAft>
-            </a:pPr>
-            <a:r>
-              <a:rPr sz="2600" b="0">
-                <a:solidFill>
-                  <a:srgbClr val="203448"/>
-                </a:solidFill>
-                <a:latin typeface="Microsoft YaHei"/>
-                <a:ea typeface="Microsoft YaHei"/>
-                <a:cs typeface="Microsoft YaHei"/>
-              </a:rPr>
-              <a:t>2  It is easy to start. ______, you only</a:t>
-            </a:r>
-          </a:p>
-          <a:p>
-            <a:pPr>
-              <a:lnSpc>
-                <a:spcPct val="112000"/>
-              </a:lnSpc>
-              <a:spcBef>
-                <a:spcPts val="0"/>
-              </a:spcBef>
-              <a:spcAft>
-                <a:spcPts val="300"/>
-              </a:spcAft>
-            </a:pPr>
-            <a:r>
-              <a:rPr sz="2600" b="0">
-                <a:solidFill>
-                  <a:srgbClr val="203448"/>
-                </a:solidFill>
-                <a:latin typeface="Microsoft YaHei"/>
-                <a:ea typeface="Microsoft YaHei"/>
-                <a:cs typeface="Microsoft YaHei"/>
-              </a:rPr>
-              <a:t>    need a ball and a court.</a:t>
-            </a:r>
-          </a:p>
-        </p:txBody>
-      </p:sp>
-      <p:sp>
-        <p:nvSpPr>
-          <p:cNvPr id="11" name="TextBox 10"/>
-          <p:cNvSpPr txBox="1"/>
-          <p:nvPr/>
-        </p:nvSpPr>
-        <p:spPr>
-          <a:xfrm>
-            <a:off x="1042415" y="3849624"/>
-            <a:ext cx="9966960" cy="438912"/>
-          </a:xfrm>
-          <a:prstGeom prst="rect">
-            <a:avLst/>
-          </a:prstGeom>
-          <a:noFill/>
-        </p:spPr>
-        <p:txBody>
-          <a:bodyPr wrap="square" lIns="109728" rIns="109728" anchor="ctr">
-            <a:spAutoFit/>
-          </a:bodyPr>
-          <a:lstStyle/>
-          <a:p>
-            <a:pPr>
-              <a:lnSpc>
-                <a:spcPct val="112000"/>
-              </a:lnSpc>
-              <a:spcBef>
-                <a:spcPts val="0"/>
-              </a:spcBef>
-              <a:spcAft>
-                <a:spcPts val="300"/>
-              </a:spcAft>
-            </a:pPr>
-            <a:r>
-              <a:rPr sz="2400" b="1">
-                <a:solidFill>
-                  <a:srgbClr val="30776D"/>
-                </a:solidFill>
-                <a:latin typeface="Microsoft YaHei"/>
-                <a:ea typeface="Microsoft YaHei"/>
-                <a:cs typeface="Microsoft YaHei"/>
-              </a:rPr>
-              <a:t>For example / For instance</a:t>
-            </a:r>
-          </a:p>
-        </p:txBody>
-      </p:sp>
-      <p:sp>
-        <p:nvSpPr>
-          <p:cNvPr id="12" name="TextBox 11"/>
-          <p:cNvSpPr txBox="1"/>
-          <p:nvPr/>
-        </p:nvSpPr>
-        <p:spPr>
-          <a:xfrm>
-            <a:off x="822960" y="4425696"/>
-            <a:ext cx="10515600" cy="786384"/>
-          </a:xfrm>
-          <a:prstGeom prst="rect">
-            <a:avLst/>
-          </a:prstGeom>
-          <a:solidFill>
-            <a:srgbClr val="EEF5FB"/>
-          </a:solidFill>
-        </p:spPr>
-        <p:txBody>
-          <a:bodyPr wrap="square" lIns="109728" rIns="109728" anchor="ctr">
-            <a:spAutoFit/>
-          </a:bodyPr>
-          <a:lstStyle/>
-          <a:p>
-            <a:pPr>
-              <a:lnSpc>
-                <a:spcPct val="112000"/>
-              </a:lnSpc>
-              <a:spcBef>
-                <a:spcPts val="0"/>
-              </a:spcBef>
-              <a:spcAft>
-                <a:spcPts val="300"/>
-              </a:spcAft>
-            </a:pPr>
-            <a:r>
-              <a:rPr sz="2600" b="0">
-                <a:solidFill>
-                  <a:srgbClr val="203448"/>
-                </a:solidFill>
-                <a:latin typeface="Microsoft YaHei"/>
-                <a:ea typeface="Microsoft YaHei"/>
-                <a:cs typeface="Microsoft YaHei"/>
-              </a:rPr>
-              <a:t>3  It is fun. It ______ helps them</a:t>
-            </a:r>
-          </a:p>
-          <a:p>
-            <a:pPr>
-              <a:lnSpc>
-                <a:spcPct val="112000"/>
-              </a:lnSpc>
-              <a:spcBef>
-                <a:spcPts val="0"/>
-              </a:spcBef>
-              <a:spcAft>
-                <a:spcPts val="300"/>
-              </a:spcAft>
-            </a:pPr>
-            <a:r>
-              <a:rPr sz="2600" b="0">
-                <a:solidFill>
-                  <a:srgbClr val="203448"/>
-                </a:solidFill>
-                <a:latin typeface="Microsoft YaHei"/>
-                <a:ea typeface="Microsoft YaHei"/>
-                <a:cs typeface="Microsoft YaHei"/>
-              </a:rPr>
-              <a:t>    relax after school.</a:t>
-            </a:r>
-          </a:p>
-        </p:txBody>
-      </p:sp>
-      <p:sp>
-        <p:nvSpPr>
-          <p:cNvPr id="13" name="TextBox 12"/>
-          <p:cNvSpPr txBox="1"/>
-          <p:nvPr/>
-        </p:nvSpPr>
-        <p:spPr>
-          <a:xfrm>
-            <a:off x="1042415" y="5239512"/>
-            <a:ext cx="9966960" cy="438912"/>
-          </a:xfrm>
-          <a:prstGeom prst="rect">
-            <a:avLst/>
-          </a:prstGeom>
-          <a:noFill/>
-        </p:spPr>
-        <p:txBody>
-          <a:bodyPr wrap="square" lIns="109728" rIns="109728" anchor="ctr">
-            <a:spAutoFit/>
-          </a:bodyPr>
-          <a:lstStyle/>
-          <a:p>
-            <a:pPr>
-              <a:lnSpc>
-                <a:spcPct val="112000"/>
-              </a:lnSpc>
-              <a:spcBef>
-                <a:spcPts val="0"/>
-              </a:spcBef>
-              <a:spcAft>
-                <a:spcPts val="300"/>
-              </a:spcAft>
-            </a:pPr>
-            <a:r>
-              <a:rPr sz="2400" b="1">
-                <a:solidFill>
-                  <a:srgbClr val="30776D"/>
-                </a:solidFill>
-                <a:latin typeface="Microsoft YaHei"/>
-                <a:ea typeface="Microsoft YaHei"/>
-                <a:cs typeface="Microsoft YaHei"/>
-              </a:rPr>
-              <a:t>also</a:t>
             </a:r>
           </a:p>
         </p:txBody>
@@ -7217,7 +8668,7 @@
                                           </p:stCondLst>
                                         </p:cTn>
                                         <p:tgtEl>
-                                          <p:spTgt spid="9"/>
+                                          <p:spTgt spid="10"/>
                                         </p:tgtEl>
                                         <p:attrNameLst>
                                           <p:attrName>style.visibility</p:attrName>
@@ -7262,7 +8713,7 @@
                                           </p:stCondLst>
                                         </p:cTn>
                                         <p:tgtEl>
-                                          <p:spTgt spid="11"/>
+                                          <p:spTgt spid="15"/>
                                         </p:tgtEl>
                                         <p:attrNameLst>
                                           <p:attrName>style.visibility</p:attrName>
@@ -7307,7 +8758,187 @@
                                           </p:stCondLst>
                                         </p:cTn>
                                         <p:tgtEl>
-                                          <p:spTgt spid="13"/>
+                                          <p:spTgt spid="21"/>
+                                        </p:tgtEl>
+                                        <p:attrNameLst>
+                                          <p:attrName>style.visibility</p:attrName>
+                                        </p:attrNameLst>
+                                      </p:cBhvr>
+                                      <p:to>
+                                        <p:strVal val="visible"/>
+                                      </p:to>
+                                    </p:set>
+                                  </p:childTnLst>
+                                </p:cTn>
+                              </p:par>
+                            </p:childTnLst>
+                          </p:cTn>
+                        </p:par>
+                      </p:childTnLst>
+                    </p:cTn>
+                  </p:par>
+                  <p:par>
+                    <p:cTn id="15" fill="hold">
+                      <p:stCondLst>
+                        <p:cond delay="indefinite"/>
+                      </p:stCondLst>
+                      <p:childTnLst>
+                        <p:par>
+                          <p:cTn id="16" fill="hold">
+                            <p:stCondLst>
+                              <p:cond delay="0"/>
+                            </p:stCondLst>
+                            <p:childTnLst>
+                              <p:par>
+                                <p:cTn id="17" presetID="1" presetClass="entr" presetSubtype="0" fill="hold" grpId="0" nodeType="clickEffect">
+                                  <p:stCondLst>
+                                    <p:cond delay="0"/>
+                                  </p:stCondLst>
+                                  <p:childTnLst>
+                                    <p:set>
+                                      <p:cBhvr>
+                                        <p:cTn id="18" dur="1" fill="hold">
+                                          <p:stCondLst>
+                                            <p:cond delay="0"/>
+                                          </p:stCondLst>
+                                        </p:cTn>
+                                        <p:tgtEl>
+                                          <p:spTgt spid="27"/>
+                                        </p:tgtEl>
+                                        <p:attrNameLst>
+                                          <p:attrName>style.visibility</p:attrName>
+                                        </p:attrNameLst>
+                                      </p:cBhvr>
+                                      <p:to>
+                                        <p:strVal val="visible"/>
+                                      </p:to>
+                                    </p:set>
+                                  </p:childTnLst>
+                                </p:cTn>
+                              </p:par>
+                            </p:childTnLst>
+                          </p:cTn>
+                        </p:par>
+                      </p:childTnLst>
+                    </p:cTn>
+                  </p:par>
+                  <p:par>
+                    <p:cTn id="19" fill="hold">
+                      <p:stCondLst>
+                        <p:cond delay="indefinite"/>
+                      </p:stCondLst>
+                      <p:childTnLst>
+                        <p:par>
+                          <p:cTn id="20" fill="hold">
+                            <p:stCondLst>
+                              <p:cond delay="0"/>
+                            </p:stCondLst>
+                            <p:childTnLst>
+                              <p:par>
+                                <p:cTn id="21" presetID="1" presetClass="entr" presetSubtype="0" fill="hold" grpId="0" nodeType="clickEffect">
+                                  <p:stCondLst>
+                                    <p:cond delay="0"/>
+                                  </p:stCondLst>
+                                  <p:childTnLst>
+                                    <p:set>
+                                      <p:cBhvr>
+                                        <p:cTn id="22" dur="1" fill="hold">
+                                          <p:stCondLst>
+                                            <p:cond delay="0"/>
+                                          </p:stCondLst>
+                                        </p:cTn>
+                                        <p:tgtEl>
+                                          <p:spTgt spid="32"/>
+                                        </p:tgtEl>
+                                        <p:attrNameLst>
+                                          <p:attrName>style.visibility</p:attrName>
+                                        </p:attrNameLst>
+                                      </p:cBhvr>
+                                      <p:to>
+                                        <p:strVal val="visible"/>
+                                      </p:to>
+                                    </p:set>
+                                  </p:childTnLst>
+                                </p:cTn>
+                              </p:par>
+                            </p:childTnLst>
+                          </p:cTn>
+                        </p:par>
+                      </p:childTnLst>
+                    </p:cTn>
+                  </p:par>
+                  <p:par>
+                    <p:cTn id="23" fill="hold">
+                      <p:stCondLst>
+                        <p:cond delay="indefinite"/>
+                      </p:stCondLst>
+                      <p:childTnLst>
+                        <p:par>
+                          <p:cTn id="24" fill="hold">
+                            <p:stCondLst>
+                              <p:cond delay="0"/>
+                            </p:stCondLst>
+                            <p:childTnLst>
+                              <p:par>
+                                <p:cTn id="25" presetID="1" presetClass="entr" presetSubtype="0" fill="hold" grpId="0" nodeType="clickEffect">
+                                  <p:stCondLst>
+                                    <p:cond delay="0"/>
+                                  </p:stCondLst>
+                                  <p:childTnLst>
+                                    <p:set>
+                                      <p:cBhvr>
+                                        <p:cTn id="26" dur="1" fill="hold">
+                                          <p:stCondLst>
+                                            <p:cond delay="0"/>
+                                          </p:stCondLst>
+                                        </p:cTn>
+                                        <p:tgtEl>
+                                          <p:spTgt spid="38"/>
+                                        </p:tgtEl>
+                                        <p:attrNameLst>
+                                          <p:attrName>style.visibility</p:attrName>
+                                        </p:attrNameLst>
+                                      </p:cBhvr>
+                                      <p:to>
+                                        <p:strVal val="visible"/>
+                                      </p:to>
+                                    </p:set>
+                                  </p:childTnLst>
+                                </p:cTn>
+                              </p:par>
+                            </p:childTnLst>
+                          </p:cTn>
+                        </p:par>
+                      </p:childTnLst>
+                    </p:cTn>
+                  </p:par>
+                  <p:par>
+                    <p:cTn id="27" fill="hold">
+                      <p:stCondLst>
+                        <p:cond delay="indefinite"/>
+                      </p:stCondLst>
+                      <p:childTnLst>
+                        <p:par>
+                          <p:cTn id="28" fill="hold">
+                            <p:stCondLst>
+                              <p:cond delay="0"/>
+                            </p:stCondLst>
+                            <p:childTnLst>
+                              <p:par>
+                                <p:cTn id="29" presetID="1" presetClass="entr" presetSubtype="0" fill="hold" grpId="0" nodeType="clickEffect">
+                                  <p:stCondLst>
+                                    <p:cond delay="0"/>
+                                  </p:stCondLst>
+                                  <p:childTnLst>
+                                    <p:set>
+                                      <p:cBhvr>
+                                        <p:cTn id="30" dur="1" fill="hold">
+                                          <p:stCondLst>
+                                            <p:cond delay="0"/>
+                                          </p:stCondLst>
+                                        </p:cTn>
+                                        <p:tgtEl>
+                                          <p:spTgt spid="43"/>
                                         </p:tgtEl>
                                         <p:attrNameLst>
                                           <p:attrName>style.visibility</p:attrName>
@@ -7348,9 +8979,13 @@
       </p:par>
     </p:tnLst>
     <p:bldLst>
-      <p:bldP spid="9" grpId="0" animBg="1"/>
-      <p:bldP spid="11" grpId="0" animBg="1"/>
-      <p:bldP spid="13" grpId="0" animBg="1"/>
+      <p:bldP spid="10" grpId="0" animBg="1"/>
+      <p:bldP spid="15" grpId="0" animBg="1"/>
+      <p:bldP spid="21" grpId="0" animBg="1"/>
+      <p:bldP spid="27" grpId="0" animBg="1"/>
+      <p:bldP spid="32" grpId="0" animBg="1"/>
+      <p:bldP spid="38" grpId="0" animBg="1"/>
+      <p:bldP spid="43" grpId="0" animBg="1"/>
     </p:bldLst>
   </p:timing>
 </p:sld>

</xml_diff>